<commit_message>
Add group member names to all assignment reports and presentations
</commit_message>
<xml_diff>
--- a/Human Computer Interaction Assignment/HCI_Presentation.pptx
+++ b/Human Computer Interaction Assignment/HCI_Presentation.pptx
@@ -2865,8 +2865,8 @@
         </p:nvSpPr>
         <p:spPr>
           <a:xfrm>
-            <a:off x="4206240" y="2926080"/>
-            <a:ext cx="4572000" cy="320040"/>
+            <a:off x="4206240" y="2788920"/>
+            <a:ext cx="4572000" cy="292608"/>
           </a:xfrm>
           <a:prstGeom prst="rect">
             <a:avLst/>
@@ -2904,8 +2904,8 @@
         </p:nvSpPr>
         <p:spPr>
           <a:xfrm>
-            <a:off x="4389120" y="3291840"/>
-            <a:ext cx="4114800" cy="292608"/>
+            <a:off x="4389120" y="3108960"/>
+            <a:ext cx="4297680" cy="256032"/>
           </a:xfrm>
           <a:prstGeom prst="rect">
             <a:avLst/>
@@ -2921,7 +2921,7 @@
               <a:buNone/>
             </a:pPr>
             <a:r>
-              <a:rPr lang="en-US" sz="1150" dirty="0">
+              <a:rPr lang="en-US" sz="1050" dirty="0">
                 <a:solidFill>
                   <a:srgbClr val="1A1A2E"/>
                 </a:solidFill>
@@ -2929,9 +2929,9 @@
                 <a:ea typeface="Calibri" pitchFamily="34" charset="-122"/>
                 <a:cs typeface="Calibri" pitchFamily="34" charset="-120"/>
               </a:rPr>
-              <a:t>1.  Ahmad Bin Ibrahim (A12345)</a:t>
-            </a:r>
-            <a:endParaRPr lang="en-US" sz="1150" dirty="0"/>
+              <a:t>1.  Al-Aqmar Bin Qaid-E Johar (1121250326560)</a:t>
+            </a:r>
+            <a:endParaRPr lang="en-US" sz="1050" dirty="0"/>
           </a:p>
         </p:txBody>
       </p:sp>
@@ -2943,8 +2943,8 @@
         </p:nvSpPr>
         <p:spPr>
           <a:xfrm>
-            <a:off x="4389120" y="3611880"/>
-            <a:ext cx="4114800" cy="292608"/>
+            <a:off x="4389120" y="3383280"/>
+            <a:ext cx="4297680" cy="256032"/>
           </a:xfrm>
           <a:prstGeom prst="rect">
             <a:avLst/>
@@ -2960,7 +2960,7 @@
               <a:buNone/>
             </a:pPr>
             <a:r>
-              <a:rPr lang="en-US" sz="1150" dirty="0">
+              <a:rPr lang="en-US" sz="1050" dirty="0">
                 <a:solidFill>
                   <a:srgbClr val="1A1A2E"/>
                 </a:solidFill>
@@ -2968,9 +2968,9 @@
                 <a:ea typeface="Calibri" pitchFamily="34" charset="-122"/>
                 <a:cs typeface="Calibri" pitchFamily="34" charset="-120"/>
               </a:rPr>
-              <a:t>2.  Sarah Binti Abdullah (A12346)</a:t>
-            </a:r>
-            <a:endParaRPr lang="en-US" sz="1150" dirty="0"/>
+              <a:t>2.  Hashem Maged Ali Alhasani (0121250326706)</a:t>
+            </a:r>
+            <a:endParaRPr lang="en-US" sz="1050" dirty="0"/>
           </a:p>
         </p:txBody>
       </p:sp>
@@ -2982,8 +2982,47 @@
         </p:nvSpPr>
         <p:spPr>
           <a:xfrm>
+            <a:off x="4389120" y="3657600"/>
+            <a:ext cx="4297680" cy="256032"/>
+          </a:xfrm>
+          <a:prstGeom prst="rect">
+            <a:avLst/>
+          </a:prstGeom>
+          <a:noFill/>
+          <a:ln/>
+        </p:spPr>
+        <p:txBody>
+          <a:bodyPr wrap="square" rtlCol="0" anchor="ctr"/>
+          <a:lstStyle/>
+          <a:p>
+            <a:pPr indent="0" marL="0">
+              <a:buNone/>
+            </a:pPr>
+            <a:r>
+              <a:rPr lang="en-US" sz="1050" dirty="0">
+                <a:solidFill>
+                  <a:srgbClr val="1A1A2E"/>
+                </a:solidFill>
+                <a:latin typeface="Calibri" pitchFamily="34" charset="0"/>
+                <a:ea typeface="Calibri" pitchFamily="34" charset="-122"/>
+                <a:cs typeface="Calibri" pitchFamily="34" charset="-120"/>
+              </a:rPr>
+              <a:t>3.  Sharjeel Muhammad (0121250326923)</a:t>
+            </a:r>
+            <a:endParaRPr lang="en-US" sz="1050" dirty="0"/>
+          </a:p>
+        </p:txBody>
+      </p:sp>
+      <p:sp>
+        <p:nvSpPr>
+          <p:cNvPr id="17" name="Text 15"/>
+          <p:cNvSpPr/>
+          <p:nvPr/>
+        </p:nvSpPr>
+        <p:spPr>
+          <a:xfrm>
             <a:off x="4389120" y="3931920"/>
-            <a:ext cx="4114800" cy="292608"/>
+            <a:ext cx="4297680" cy="256032"/>
           </a:xfrm>
           <a:prstGeom prst="rect">
             <a:avLst/>
@@ -2999,7 +3038,7 @@
               <a:buNone/>
             </a:pPr>
             <a:r>
-              <a:rPr lang="en-US" sz="1150" dirty="0">
+              <a:rPr lang="en-US" sz="1050" dirty="0">
                 <a:solidFill>
                   <a:srgbClr val="1A1A2E"/>
                 </a:solidFill>
@@ -3007,22 +3046,22 @@
                 <a:ea typeface="Calibri" pitchFamily="34" charset="-122"/>
                 <a:cs typeface="Calibri" pitchFamily="34" charset="-120"/>
               </a:rPr>
-              <a:t>3.  Muhammad Hafiz Bin Razak (A12347)</a:t>
-            </a:r>
-            <a:endParaRPr lang="en-US" sz="1150" dirty="0"/>
-          </a:p>
-        </p:txBody>
-      </p:sp>
-      <p:sp>
-        <p:nvSpPr>
-          <p:cNvPr id="17" name="Text 15"/>
-          <p:cNvSpPr/>
-          <p:nvPr/>
-        </p:nvSpPr>
-        <p:spPr>
-          <a:xfrm>
-            <a:off x="4389120" y="4251960"/>
-            <a:ext cx="4114800" cy="292608"/>
+              <a:t>4.  Abdullah Saleh Abdullah (0121250326783)</a:t>
+            </a:r>
+            <a:endParaRPr lang="en-US" sz="1050" dirty="0"/>
+          </a:p>
+        </p:txBody>
+      </p:sp>
+      <p:sp>
+        <p:nvSpPr>
+          <p:cNvPr id="18" name="Text 16"/>
+          <p:cNvSpPr/>
+          <p:nvPr/>
+        </p:nvSpPr>
+        <p:spPr>
+          <a:xfrm>
+            <a:off x="4389120" y="4206240"/>
+            <a:ext cx="4297680" cy="256032"/>
           </a:xfrm>
           <a:prstGeom prst="rect">
             <a:avLst/>
@@ -3038,7 +3077,7 @@
               <a:buNone/>
             </a:pPr>
             <a:r>
-              <a:rPr lang="en-US" sz="1150" dirty="0">
+              <a:rPr lang="en-US" sz="1050" dirty="0">
                 <a:solidFill>
                   <a:srgbClr val="1A1A2E"/>
                 </a:solidFill>
@@ -3046,22 +3085,22 @@
                 <a:ea typeface="Calibri" pitchFamily="34" charset="-122"/>
                 <a:cs typeface="Calibri" pitchFamily="34" charset="-120"/>
               </a:rPr>
-              <a:t>4.  Nurul Aisyah Binti Hassan (A12348)</a:t>
-            </a:r>
-            <a:endParaRPr lang="en-US" sz="1150" dirty="0"/>
-          </a:p>
-        </p:txBody>
-      </p:sp>
-      <p:sp>
-        <p:nvSpPr>
-          <p:cNvPr id="18" name="Text 16"/>
-          <p:cNvSpPr/>
-          <p:nvPr/>
-        </p:nvSpPr>
-        <p:spPr>
-          <a:xfrm>
-            <a:off x="4389120" y="4572000"/>
-            <a:ext cx="4114800" cy="292608"/>
+              <a:t>5.  Ateegalla Fadlalseed Ateegalla Ahmed (0121250326810)</a:t>
+            </a:r>
+            <a:endParaRPr lang="en-US" sz="1050" dirty="0"/>
+          </a:p>
+        </p:txBody>
+      </p:sp>
+      <p:sp>
+        <p:nvSpPr>
+          <p:cNvPr id="19" name="Text 17"/>
+          <p:cNvSpPr/>
+          <p:nvPr/>
+        </p:nvSpPr>
+        <p:spPr>
+          <a:xfrm>
+            <a:off x="4389120" y="4480560"/>
+            <a:ext cx="4297680" cy="256032"/>
           </a:xfrm>
           <a:prstGeom prst="rect">
             <a:avLst/>
@@ -3077,7 +3116,7 @@
               <a:buNone/>
             </a:pPr>
             <a:r>
-              <a:rPr lang="en-US" sz="1150" dirty="0">
+              <a:rPr lang="en-US" sz="1050" dirty="0">
                 <a:solidFill>
                   <a:srgbClr val="1A1A2E"/>
                 </a:solidFill>
@@ -3085,15 +3124,15 @@
                 <a:ea typeface="Calibri" pitchFamily="34" charset="-122"/>
                 <a:cs typeface="Calibri" pitchFamily="34" charset="-120"/>
               </a:rPr>
-              <a:t>5.  David Tan Wei Ming (A12349)</a:t>
-            </a:r>
-            <a:endParaRPr lang="en-US" sz="1150" dirty="0"/>
-          </a:p>
-        </p:txBody>
-      </p:sp>
-      <p:sp>
-        <p:nvSpPr>
-          <p:cNvPr id="19" name="Text 17"/>
+              <a:t>6.  Ibrahim Muhammad (0121250326708)</a:t>
+            </a:r>
+            <a:endParaRPr lang="en-US" sz="1050" dirty="0"/>
+          </a:p>
+        </p:txBody>
+      </p:sp>
+      <p:sp>
+        <p:nvSpPr>
+          <p:cNvPr id="20" name="Text 18"/>
           <p:cNvSpPr/>
           <p:nvPr/>
         </p:nvSpPr>
@@ -11804,7 +11843,7 @@
               <a:buNone/>
             </a:pPr>
             <a:r>
-              <a:rPr lang="en-US" sz="1150" dirty="0">
+              <a:rPr lang="en-US" sz="1100" dirty="0">
                 <a:solidFill>
                   <a:srgbClr val="7A8FAA"/>
                 </a:solidFill>
@@ -11812,9 +11851,9 @@
                 <a:ea typeface="Calibri" pitchFamily="34" charset="-122"/>
                 <a:cs typeface="Calibri" pitchFamily="34" charset="-120"/>
               </a:rPr>
-              <a:t>Ahmad Bin Ibrahim  |  Sarah Binti Abdullah  |  Muhammad Hafiz Bin Razak</a:t>
-            </a:r>
-            <a:endParaRPr lang="en-US" sz="1150" dirty="0"/>
+              <a:t>Al-Aqmar Bin Qaid-E Johar  |  Hashem Maged Ali Alhasani  |  Sharjeel Muhammad</a:t>
+            </a:r>
+            <a:endParaRPr lang="en-US" sz="1100" dirty="0"/>
           </a:p>
           <a:p>
             <a:pPr algn="ctr" indent="0" marL="0">
@@ -11824,7 +11863,7 @@
               <a:buNone/>
             </a:pPr>
             <a:r>
-              <a:rPr lang="en-US" sz="1150" dirty="0">
+              <a:rPr lang="en-US" sz="1100" dirty="0">
                 <a:solidFill>
                   <a:srgbClr val="7A8FAA"/>
                 </a:solidFill>
@@ -11832,9 +11871,9 @@
                 <a:ea typeface="Calibri" pitchFamily="34" charset="-122"/>
                 <a:cs typeface="Calibri" pitchFamily="34" charset="-120"/>
               </a:rPr>
-              <a:t>Nurul Aisyah Binti Hassan  |  David Tan Wei Ming</a:t>
-            </a:r>
-            <a:endParaRPr lang="en-US" sz="1150" dirty="0"/>
+              <a:t>Abdullah Saleh Abdullah  |  Ateegalla Fadlalseed Ateegalla Ahmed  |  Ibrahim Muhammad</a:t>
+            </a:r>
+            <a:endParaRPr lang="en-US" sz="1100" dirty="0"/>
           </a:p>
         </p:txBody>
       </p:sp>

</xml_diff>

<commit_message>
Regenerate HCI presentation with Ms. Ajeerah lecturer name
</commit_message>
<xml_diff>
--- a/Human Computer Interaction Assignment/HCI_Presentation.pptx
+++ b/Human Computer Interaction Assignment/HCI_Presentation.pptx
@@ -2851,7 +2851,7 @@
                 <a:ea typeface="Calibri" pitchFamily="34" charset="-122"/>
                 <a:cs typeface="Calibri" pitchFamily="34" charset="-120"/>
               </a:rPr>
-              <a:t>Lecturer: Dr. Noraini Binti Mohd Razali</a:t>
+              <a:t>Lecturer: Ms. Ajeerah</a:t>
             </a:r>
             <a:endParaRPr lang="en-US" sz="1200" dirty="0"/>
           </a:p>
@@ -2905,19 +2905,19 @@
         <p:spPr>
           <a:xfrm>
             <a:off x="4389120" y="3108960"/>
-            <a:ext cx="4297680" cy="256032"/>
-          </a:xfrm>
-          <a:prstGeom prst="rect">
-            <a:avLst/>
-          </a:prstGeom>
-          <a:noFill/>
-          <a:ln/>
-        </p:spPr>
-        <p:txBody>
-          <a:bodyPr wrap="square" rtlCol="0" anchor="ctr"/>
-          <a:lstStyle/>
-          <a:p>
-            <a:pPr indent="0" marL="0">
+            <a:ext cx="320040" cy="256032"/>
+          </a:xfrm>
+          <a:prstGeom prst="rect">
+            <a:avLst/>
+          </a:prstGeom>
+          <a:noFill/>
+          <a:ln/>
+        </p:spPr>
+        <p:txBody>
+          <a:bodyPr wrap="square" rtlCol="0" anchor="ctr"/>
+          <a:lstStyle/>
+          <a:p>
+            <a:pPr algn="l" indent="0" marL="0">
               <a:buNone/>
             </a:pPr>
             <a:r>
@@ -2929,7 +2929,7 @@
                 <a:ea typeface="Calibri" pitchFamily="34" charset="-122"/>
                 <a:cs typeface="Calibri" pitchFamily="34" charset="-120"/>
               </a:rPr>
-              <a:t>1.  Al-Aqmar Bin Qaid-E Johar (1121250326560)</a:t>
+              <a:t>1.</a:t>
             </a:r>
             <a:endParaRPr lang="en-US" sz="1050" dirty="0"/>
           </a:p>
@@ -2943,20 +2943,59 @@
         </p:nvSpPr>
         <p:spPr>
           <a:xfrm>
+            <a:off x="4709160" y="3108960"/>
+            <a:ext cx="4069080" cy="256032"/>
+          </a:xfrm>
+          <a:prstGeom prst="rect">
+            <a:avLst/>
+          </a:prstGeom>
+          <a:noFill/>
+          <a:ln/>
+        </p:spPr>
+        <p:txBody>
+          <a:bodyPr wrap="square" rtlCol="0" anchor="ctr"/>
+          <a:lstStyle/>
+          <a:p>
+            <a:pPr algn="l" indent="0" marL="0">
+              <a:buNone/>
+            </a:pPr>
+            <a:r>
+              <a:rPr lang="en-US" sz="1050" dirty="0">
+                <a:solidFill>
+                  <a:srgbClr val="1A1A2E"/>
+                </a:solidFill>
+                <a:latin typeface="Calibri" pitchFamily="34" charset="0"/>
+                <a:ea typeface="Calibri" pitchFamily="34" charset="-122"/>
+                <a:cs typeface="Calibri" pitchFamily="34" charset="-120"/>
+              </a:rPr>
+              <a:t>Al-Aqmar Bin Qaid-E Johar (1121250326560)</a:t>
+            </a:r>
+            <a:endParaRPr lang="en-US" sz="1050" dirty="0"/>
+          </a:p>
+        </p:txBody>
+      </p:sp>
+      <p:sp>
+        <p:nvSpPr>
+          <p:cNvPr id="16" name="Text 14"/>
+          <p:cNvSpPr/>
+          <p:nvPr/>
+        </p:nvSpPr>
+        <p:spPr>
+          <a:xfrm>
             <a:off x="4389120" y="3383280"/>
-            <a:ext cx="4297680" cy="256032"/>
-          </a:xfrm>
-          <a:prstGeom prst="rect">
-            <a:avLst/>
-          </a:prstGeom>
-          <a:noFill/>
-          <a:ln/>
-        </p:spPr>
-        <p:txBody>
-          <a:bodyPr wrap="square" rtlCol="0" anchor="ctr"/>
-          <a:lstStyle/>
-          <a:p>
-            <a:pPr indent="0" marL="0">
+            <a:ext cx="320040" cy="256032"/>
+          </a:xfrm>
+          <a:prstGeom prst="rect">
+            <a:avLst/>
+          </a:prstGeom>
+          <a:noFill/>
+          <a:ln/>
+        </p:spPr>
+        <p:txBody>
+          <a:bodyPr wrap="square" rtlCol="0" anchor="ctr"/>
+          <a:lstStyle/>
+          <a:p>
+            <a:pPr algn="l" indent="0" marL="0">
               <a:buNone/>
             </a:pPr>
             <a:r>
@@ -2968,7 +3007,7 @@
                 <a:ea typeface="Calibri" pitchFamily="34" charset="-122"/>
                 <a:cs typeface="Calibri" pitchFamily="34" charset="-120"/>
               </a:rPr>
-              <a:t>2.  Hashem Maged Ali Alhasani (0121250326706)</a:t>
+              <a:t>2.</a:t>
             </a:r>
             <a:endParaRPr lang="en-US" sz="1050" dirty="0"/>
           </a:p>
@@ -2976,26 +3015,65 @@
       </p:sp>
       <p:sp>
         <p:nvSpPr>
-          <p:cNvPr id="16" name="Text 14"/>
+          <p:cNvPr id="17" name="Text 15"/>
+          <p:cNvSpPr/>
+          <p:nvPr/>
+        </p:nvSpPr>
+        <p:spPr>
+          <a:xfrm>
+            <a:off x="4709160" y="3383280"/>
+            <a:ext cx="4069080" cy="256032"/>
+          </a:xfrm>
+          <a:prstGeom prst="rect">
+            <a:avLst/>
+          </a:prstGeom>
+          <a:noFill/>
+          <a:ln/>
+        </p:spPr>
+        <p:txBody>
+          <a:bodyPr wrap="square" rtlCol="0" anchor="ctr"/>
+          <a:lstStyle/>
+          <a:p>
+            <a:pPr algn="l" indent="0" marL="0">
+              <a:buNone/>
+            </a:pPr>
+            <a:r>
+              <a:rPr lang="en-US" sz="1050" dirty="0">
+                <a:solidFill>
+                  <a:srgbClr val="1A1A2E"/>
+                </a:solidFill>
+                <a:latin typeface="Calibri" pitchFamily="34" charset="0"/>
+                <a:ea typeface="Calibri" pitchFamily="34" charset="-122"/>
+                <a:cs typeface="Calibri" pitchFamily="34" charset="-120"/>
+              </a:rPr>
+              <a:t>Hashem Maged Ali Alhasani (0121250326706)</a:t>
+            </a:r>
+            <a:endParaRPr lang="en-US" sz="1050" dirty="0"/>
+          </a:p>
+        </p:txBody>
+      </p:sp>
+      <p:sp>
+        <p:nvSpPr>
+          <p:cNvPr id="18" name="Text 16"/>
           <p:cNvSpPr/>
           <p:nvPr/>
         </p:nvSpPr>
         <p:spPr>
           <a:xfrm>
             <a:off x="4389120" y="3657600"/>
-            <a:ext cx="4297680" cy="256032"/>
-          </a:xfrm>
-          <a:prstGeom prst="rect">
-            <a:avLst/>
-          </a:prstGeom>
-          <a:noFill/>
-          <a:ln/>
-        </p:spPr>
-        <p:txBody>
-          <a:bodyPr wrap="square" rtlCol="0" anchor="ctr"/>
-          <a:lstStyle/>
-          <a:p>
-            <a:pPr indent="0" marL="0">
+            <a:ext cx="320040" cy="256032"/>
+          </a:xfrm>
+          <a:prstGeom prst="rect">
+            <a:avLst/>
+          </a:prstGeom>
+          <a:noFill/>
+          <a:ln/>
+        </p:spPr>
+        <p:txBody>
+          <a:bodyPr wrap="square" rtlCol="0" anchor="ctr"/>
+          <a:lstStyle/>
+          <a:p>
+            <a:pPr algn="l" indent="0" marL="0">
               <a:buNone/>
             </a:pPr>
             <a:r>
@@ -3007,7 +3085,7 @@
                 <a:ea typeface="Calibri" pitchFamily="34" charset="-122"/>
                 <a:cs typeface="Calibri" pitchFamily="34" charset="-120"/>
               </a:rPr>
-              <a:t>3.  Sharjeel Muhammad (0121250326923)</a:t>
+              <a:t>3.</a:t>
             </a:r>
             <a:endParaRPr lang="en-US" sz="1050" dirty="0"/>
           </a:p>
@@ -3015,26 +3093,65 @@
       </p:sp>
       <p:sp>
         <p:nvSpPr>
-          <p:cNvPr id="17" name="Text 15"/>
+          <p:cNvPr id="19" name="Text 17"/>
+          <p:cNvSpPr/>
+          <p:nvPr/>
+        </p:nvSpPr>
+        <p:spPr>
+          <a:xfrm>
+            <a:off x="4709160" y="3657600"/>
+            <a:ext cx="4069080" cy="256032"/>
+          </a:xfrm>
+          <a:prstGeom prst="rect">
+            <a:avLst/>
+          </a:prstGeom>
+          <a:noFill/>
+          <a:ln/>
+        </p:spPr>
+        <p:txBody>
+          <a:bodyPr wrap="square" rtlCol="0" anchor="ctr"/>
+          <a:lstStyle/>
+          <a:p>
+            <a:pPr algn="l" indent="0" marL="0">
+              <a:buNone/>
+            </a:pPr>
+            <a:r>
+              <a:rPr lang="en-US" sz="1050" dirty="0">
+                <a:solidFill>
+                  <a:srgbClr val="1A1A2E"/>
+                </a:solidFill>
+                <a:latin typeface="Calibri" pitchFamily="34" charset="0"/>
+                <a:ea typeface="Calibri" pitchFamily="34" charset="-122"/>
+                <a:cs typeface="Calibri" pitchFamily="34" charset="-120"/>
+              </a:rPr>
+              <a:t>Sharjeel Muhammad (0121250326923)</a:t>
+            </a:r>
+            <a:endParaRPr lang="en-US" sz="1050" dirty="0"/>
+          </a:p>
+        </p:txBody>
+      </p:sp>
+      <p:sp>
+        <p:nvSpPr>
+          <p:cNvPr id="20" name="Text 18"/>
           <p:cNvSpPr/>
           <p:nvPr/>
         </p:nvSpPr>
         <p:spPr>
           <a:xfrm>
             <a:off x="4389120" y="3931920"/>
-            <a:ext cx="4297680" cy="256032"/>
-          </a:xfrm>
-          <a:prstGeom prst="rect">
-            <a:avLst/>
-          </a:prstGeom>
-          <a:noFill/>
-          <a:ln/>
-        </p:spPr>
-        <p:txBody>
-          <a:bodyPr wrap="square" rtlCol="0" anchor="ctr"/>
-          <a:lstStyle/>
-          <a:p>
-            <a:pPr indent="0" marL="0">
+            <a:ext cx="320040" cy="256032"/>
+          </a:xfrm>
+          <a:prstGeom prst="rect">
+            <a:avLst/>
+          </a:prstGeom>
+          <a:noFill/>
+          <a:ln/>
+        </p:spPr>
+        <p:txBody>
+          <a:bodyPr wrap="square" rtlCol="0" anchor="ctr"/>
+          <a:lstStyle/>
+          <a:p>
+            <a:pPr algn="l" indent="0" marL="0">
               <a:buNone/>
             </a:pPr>
             <a:r>
@@ -3046,7 +3163,7 @@
                 <a:ea typeface="Calibri" pitchFamily="34" charset="-122"/>
                 <a:cs typeface="Calibri" pitchFamily="34" charset="-120"/>
               </a:rPr>
-              <a:t>4.  Abdullah Saleh Abdullah (0121250326783)</a:t>
+              <a:t>4.</a:t>
             </a:r>
             <a:endParaRPr lang="en-US" sz="1050" dirty="0"/>
           </a:p>
@@ -3054,26 +3171,65 @@
       </p:sp>
       <p:sp>
         <p:nvSpPr>
-          <p:cNvPr id="18" name="Text 16"/>
+          <p:cNvPr id="21" name="Text 19"/>
+          <p:cNvSpPr/>
+          <p:nvPr/>
+        </p:nvSpPr>
+        <p:spPr>
+          <a:xfrm>
+            <a:off x="4709160" y="3931920"/>
+            <a:ext cx="4069080" cy="256032"/>
+          </a:xfrm>
+          <a:prstGeom prst="rect">
+            <a:avLst/>
+          </a:prstGeom>
+          <a:noFill/>
+          <a:ln/>
+        </p:spPr>
+        <p:txBody>
+          <a:bodyPr wrap="square" rtlCol="0" anchor="ctr"/>
+          <a:lstStyle/>
+          <a:p>
+            <a:pPr algn="l" indent="0" marL="0">
+              <a:buNone/>
+            </a:pPr>
+            <a:r>
+              <a:rPr lang="en-US" sz="1050" dirty="0">
+                <a:solidFill>
+                  <a:srgbClr val="1A1A2E"/>
+                </a:solidFill>
+                <a:latin typeface="Calibri" pitchFamily="34" charset="0"/>
+                <a:ea typeface="Calibri" pitchFamily="34" charset="-122"/>
+                <a:cs typeface="Calibri" pitchFamily="34" charset="-120"/>
+              </a:rPr>
+              <a:t>Abdullah Saleh Abdullah (0121250326783)</a:t>
+            </a:r>
+            <a:endParaRPr lang="en-US" sz="1050" dirty="0"/>
+          </a:p>
+        </p:txBody>
+      </p:sp>
+      <p:sp>
+        <p:nvSpPr>
+          <p:cNvPr id="22" name="Text 20"/>
           <p:cNvSpPr/>
           <p:nvPr/>
         </p:nvSpPr>
         <p:spPr>
           <a:xfrm>
             <a:off x="4389120" y="4206240"/>
-            <a:ext cx="4297680" cy="256032"/>
-          </a:xfrm>
-          <a:prstGeom prst="rect">
-            <a:avLst/>
-          </a:prstGeom>
-          <a:noFill/>
-          <a:ln/>
-        </p:spPr>
-        <p:txBody>
-          <a:bodyPr wrap="square" rtlCol="0" anchor="ctr"/>
-          <a:lstStyle/>
-          <a:p>
-            <a:pPr indent="0" marL="0">
+            <a:ext cx="320040" cy="256032"/>
+          </a:xfrm>
+          <a:prstGeom prst="rect">
+            <a:avLst/>
+          </a:prstGeom>
+          <a:noFill/>
+          <a:ln/>
+        </p:spPr>
+        <p:txBody>
+          <a:bodyPr wrap="square" rtlCol="0" anchor="ctr"/>
+          <a:lstStyle/>
+          <a:p>
+            <a:pPr algn="l" indent="0" marL="0">
               <a:buNone/>
             </a:pPr>
             <a:r>
@@ -3085,7 +3241,7 @@
                 <a:ea typeface="Calibri" pitchFamily="34" charset="-122"/>
                 <a:cs typeface="Calibri" pitchFamily="34" charset="-120"/>
               </a:rPr>
-              <a:t>5.  Ateegalla Fadlalseed Ateegalla Ahmed (0121250326810)</a:t>
+              <a:t>5.</a:t>
             </a:r>
             <a:endParaRPr lang="en-US" sz="1050" dirty="0"/>
           </a:p>
@@ -3093,26 +3249,65 @@
       </p:sp>
       <p:sp>
         <p:nvSpPr>
-          <p:cNvPr id="19" name="Text 17"/>
+          <p:cNvPr id="23" name="Text 21"/>
+          <p:cNvSpPr/>
+          <p:nvPr/>
+        </p:nvSpPr>
+        <p:spPr>
+          <a:xfrm>
+            <a:off x="4709160" y="4206240"/>
+            <a:ext cx="4069080" cy="256032"/>
+          </a:xfrm>
+          <a:prstGeom prst="rect">
+            <a:avLst/>
+          </a:prstGeom>
+          <a:noFill/>
+          <a:ln/>
+        </p:spPr>
+        <p:txBody>
+          <a:bodyPr wrap="square" rtlCol="0" anchor="ctr"/>
+          <a:lstStyle/>
+          <a:p>
+            <a:pPr algn="l" indent="0" marL="0">
+              <a:buNone/>
+            </a:pPr>
+            <a:r>
+              <a:rPr lang="en-US" sz="1050" dirty="0">
+                <a:solidFill>
+                  <a:srgbClr val="1A1A2E"/>
+                </a:solidFill>
+                <a:latin typeface="Calibri" pitchFamily="34" charset="0"/>
+                <a:ea typeface="Calibri" pitchFamily="34" charset="-122"/>
+                <a:cs typeface="Calibri" pitchFamily="34" charset="-120"/>
+              </a:rPr>
+              <a:t>Ateegalla Fadlalseed Ateegalla Ahmed (0121250326810)</a:t>
+            </a:r>
+            <a:endParaRPr lang="en-US" sz="1050" dirty="0"/>
+          </a:p>
+        </p:txBody>
+      </p:sp>
+      <p:sp>
+        <p:nvSpPr>
+          <p:cNvPr id="24" name="Text 22"/>
           <p:cNvSpPr/>
           <p:nvPr/>
         </p:nvSpPr>
         <p:spPr>
           <a:xfrm>
             <a:off x="4389120" y="4480560"/>
-            <a:ext cx="4297680" cy="256032"/>
-          </a:xfrm>
-          <a:prstGeom prst="rect">
-            <a:avLst/>
-          </a:prstGeom>
-          <a:noFill/>
-          <a:ln/>
-        </p:spPr>
-        <p:txBody>
-          <a:bodyPr wrap="square" rtlCol="0" anchor="ctr"/>
-          <a:lstStyle/>
-          <a:p>
-            <a:pPr indent="0" marL="0">
+            <a:ext cx="320040" cy="256032"/>
+          </a:xfrm>
+          <a:prstGeom prst="rect">
+            <a:avLst/>
+          </a:prstGeom>
+          <a:noFill/>
+          <a:ln/>
+        </p:spPr>
+        <p:txBody>
+          <a:bodyPr wrap="square" rtlCol="0" anchor="ctr"/>
+          <a:lstStyle/>
+          <a:p>
+            <a:pPr algn="l" indent="0" marL="0">
               <a:buNone/>
             </a:pPr>
             <a:r>
@@ -3124,7 +3319,7 @@
                 <a:ea typeface="Calibri" pitchFamily="34" charset="-122"/>
                 <a:cs typeface="Calibri" pitchFamily="34" charset="-120"/>
               </a:rPr>
-              <a:t>6.  Ibrahim Muhammad (0121250326708)</a:t>
+              <a:t>6.</a:t>
             </a:r>
             <a:endParaRPr lang="en-US" sz="1050" dirty="0"/>
           </a:p>
@@ -3132,7 +3327,46 @@
       </p:sp>
       <p:sp>
         <p:nvSpPr>
-          <p:cNvPr id="20" name="Text 18"/>
+          <p:cNvPr id="25" name="Text 23"/>
+          <p:cNvSpPr/>
+          <p:nvPr/>
+        </p:nvSpPr>
+        <p:spPr>
+          <a:xfrm>
+            <a:off x="4709160" y="4480560"/>
+            <a:ext cx="4069080" cy="256032"/>
+          </a:xfrm>
+          <a:prstGeom prst="rect">
+            <a:avLst/>
+          </a:prstGeom>
+          <a:noFill/>
+          <a:ln/>
+        </p:spPr>
+        <p:txBody>
+          <a:bodyPr wrap="square" rtlCol="0" anchor="ctr"/>
+          <a:lstStyle/>
+          <a:p>
+            <a:pPr algn="l" indent="0" marL="0">
+              <a:buNone/>
+            </a:pPr>
+            <a:r>
+              <a:rPr lang="en-US" sz="1050" dirty="0">
+                <a:solidFill>
+                  <a:srgbClr val="1A1A2E"/>
+                </a:solidFill>
+                <a:latin typeface="Calibri" pitchFamily="34" charset="0"/>
+                <a:ea typeface="Calibri" pitchFamily="34" charset="-122"/>
+                <a:cs typeface="Calibri" pitchFamily="34" charset="-120"/>
+              </a:rPr>
+              <a:t>Ibrahim Muhammad (0121250326708)</a:t>
+            </a:r>
+            <a:endParaRPr lang="en-US" sz="1050" dirty="0"/>
+          </a:p>
+        </p:txBody>
+      </p:sp>
+      <p:sp>
+        <p:nvSpPr>
+          <p:cNvPr id="26" name="Text 24"/>
           <p:cNvSpPr/>
           <p:nvPr/>
         </p:nvSpPr>
@@ -11949,7 +12183,7 @@
                 <a:ea typeface="Calibri" pitchFamily="34" charset="-122"/>
                 <a:cs typeface="Calibri" pitchFamily="34" charset="-120"/>
               </a:rPr>
-              <a:t>Human Computer Interaction  |  Dr. Noraini Binti Mohd Razali  |  2026</a:t>
+              <a:t>Human Computer Interaction  |  Ms. Ajeerah  |  2026</a:t>
             </a:r>
             <a:endParaRPr lang="en-US" sz="1000" dirty="0"/>
           </a:p>

</xml_diff>